<commit_message>
docs: update presentation slides with Probe IP, OUI vendor recognition, and DB history
</commit_message>
<xml_diff>
--- a/NetScan_Pro_Presentation.pptx
+++ b/NetScan_Pro_Presentation.pptx
@@ -3918,7 +3918,7 @@
               </a:defRPr>
             </a:pPr>
             <a:r>
-              <a:t>1. Subnet Auto-Detection — </a:t>
+              <a:t>1. Subnet &amp; Interface Auto-Detection — </a:t>
             </a:r>
             <a:r>
               <a:rPr sz="1300" b="0">
@@ -3926,7 +3926,7 @@
                   <a:srgbClr val="FFFFFF"/>
                 </a:solidFill>
               </a:rPr>
-              <a:t>Inspects host network interfaces to automatically detect local IP and calculate the subnet CIDR (e.g., 192.168.1.0/24).</a:t>
+              <a:t>Inspects physical network adapters (Wi-Fi/Ethernet) to detect host IP and calculate the CIDR subnet (e.g., 192.168.1.0/24 or 172.20.160.0/19).</a:t>
             </a:r>
           </a:p>
         </p:txBody>
@@ -4006,7 +4006,7 @@
               </a:defRPr>
             </a:pPr>
             <a:r>
-              <a:t>2. Batched Ping Sweeps — </a:t>
+              <a:t>2. Batched Ping Sweeps &amp; Concurrency — </a:t>
             </a:r>
             <a:r>
               <a:rPr sz="1300" b="0">
@@ -4014,7 +4014,7 @@
                   <a:srgbClr val="FFFFFF"/>
                 </a:solidFill>
               </a:rPr>
-              <a:t>Executes concurrency-controlled ping sweeps across all 254 IP addresses every 10 seconds to discover alive hosts and measure latency.</a:t>
+              <a:t>Executes concurrency-controlled ping sweeps across all 254 IP addresses every 6 seconds to discover alive hosts and measure latency without freezing.</a:t>
             </a:r>
           </a:p>
         </p:txBody>
@@ -4094,7 +4094,7 @@
               </a:defRPr>
             </a:pPr>
             <a:r>
-              <a:t>3. Hostname &amp; MAC Lookup — </a:t>
+              <a:t>3. ARP Inspection &amp; Hardware OUI Resolution — </a:t>
             </a:r>
             <a:r>
               <a:rPr sz="1300" b="0">
@@ -4102,7 +4102,7 @@
                   <a:srgbClr val="FFFFFF"/>
                 </a:solidFill>
               </a:rPr>
-              <a:t>Queries reverse DNS, system host tables, and ARP caches to identify hardware vendors and device hostnames.</a:t>
+              <a:t>Extracts hardware MAC addresses from the ARP cache and matches OUI prefixes to identify manufacturers (Apple, Samsung, Intel, HP).</a:t>
             </a:r>
           </a:p>
         </p:txBody>
@@ -4182,7 +4182,7 @@
               </a:defRPr>
             </a:pPr>
             <a:r>
-              <a:t>4. Device Categorization — </a:t>
+              <a:t>4. Targeted Unicast IP Probing (⚡ Probe IP) — </a:t>
             </a:r>
             <a:r>
               <a:rPr sz="1300" b="0">
@@ -4190,7 +4190,7 @@
                   <a:srgbClr val="FFFFFF"/>
                 </a:solidFill>
               </a:rPr>
-              <a:t>Analyzes naming patterns and MAC signatures to classify devices into Laptops, Mobiles, TVs, Printers, and Routers.</a:t>
+              <a:t>Allows administrators to enter custom IPs (e.g., 172.20.181.188) to probe and track cross-subnet nodes or silent clients on demand.</a:t>
             </a:r>
           </a:p>
         </p:txBody>
@@ -4270,7 +4270,7 @@
               </a:defRPr>
             </a:pPr>
             <a:r>
-              <a:t>5. Live WebSocket Sync — </a:t>
+              <a:t>5. SQLite Persistence &amp; Live WebSocket Sync — </a:t>
             </a:r>
             <a:r>
               <a:rPr sz="1300" b="0">
@@ -4278,7 +4278,7 @@
                   <a:srgbClr val="FFFFFF"/>
                 </a:solidFill>
               </a:rPr>
-              <a:t>Pushes real-time state changes (connect, disconnect, reconnect) instantly to connected browser clients via Socket.io.</a:t>
+              <a:t>Logs every connection/disconnection event permanently in SQLite with timestamps and broadcasts live state updates via Socket.IO.</a:t>
             </a:r>
           </a:p>
         </p:txBody>
@@ -4492,7 +4492,7 @@
               </a:defRPr>
             </a:pPr>
             <a:r>
-              <a:t>⏱️  Real-Time Latency Badges</a:t>
+              <a:t>🎯  ⚡ On-Demand Target Probing (Probe IP)</a:t>
             </a:r>
           </a:p>
           <a:p>
@@ -4504,7 +4504,7 @@
               </a:defRPr>
             </a:pPr>
             <a:r>
-              <a:t>Accurately measures and displays round-trip ping latency in milliseconds (ms) for every active device.</a:t>
+              <a:t>Enter any specific IP to send direct ICMP/ARP probes and force-track custom or cross-subnet nodes.</a:t>
             </a:r>
           </a:p>
         </p:txBody>
@@ -4587,7 +4587,7 @@
               </a:defRPr>
             </a:pPr>
             <a:r>
-              <a:t>🔔  Instant Toast Alerts</a:t>
+              <a:t>💾  📜 Persistent DB History &amp; CSV Export</a:t>
             </a:r>
           </a:p>
           <a:p>
@@ -4599,7 +4599,7 @@
               </a:defRPr>
             </a:pPr>
             <a:r>
-              <a:t>Pops up notifications in real time when a new device joins or an existing device drops off the network.</a:t>
+              <a:t>Full historical audit trail in SQLite recording every connect/disconnect event with 1-click CSV download.</a:t>
             </a:r>
           </a:p>
         </p:txBody>
@@ -4682,7 +4682,7 @@
               </a:defRPr>
             </a:pPr>
             <a:r>
-              <a:t>🔍  Category &amp; Search Filters</a:t>
+              <a:t>🏷️  🏷️ Hardware Vendor Identification</a:t>
             </a:r>
           </a:p>
           <a:p>
@@ -4694,7 +4694,7 @@
               </a:defRPr>
             </a:pPr>
             <a:r>
-              <a:t>Instantly filter devices by category (Laptop, Phone, TV, Printer) or search by IP, hostname, or MAC.</a:t>
+              <a:t>Automatic MAC OUI dictionary matching identifies Apple, Samsung, OnePlus, Dell, HP, Xiaomi, and Google devices.</a:t>
             </a:r>
           </a:p>
         </p:txBody>
@@ -4777,7 +4777,7 @@
               </a:defRPr>
             </a:pPr>
             <a:r>
-              <a:t>⚡  On-Demand Manual Scan</a:t>
+              <a:t>🔔  🔔 Real-Time Live Toast Alerts</a:t>
             </a:r>
           </a:p>
           <a:p>
@@ -4789,7 +4789,7 @@
               </a:defRPr>
             </a:pPr>
             <a:r>
-              <a:t>Allows users to trigger immediate network sweeps with a single click, bypassing the automatic timer.</a:t>
+              <a:t>Instant green/red popups when devices connect or drop off without requiring page reloads.</a:t>
             </a:r>
           </a:p>
         </p:txBody>
@@ -4872,7 +4872,7 @@
               </a:defRPr>
             </a:pPr>
             <a:r>
-              <a:t>🟢  Live Connection Heartbeat</a:t>
+              <a:t>⏱️  ⏱️ Dynamic Live Uptime &amp; Latency</a:t>
             </a:r>
           </a:p>
           <a:p>
@@ -4884,7 +4884,7 @@
               </a:defRPr>
             </a:pPr>
             <a:r>
-              <a:t>Visual status indicators and pulse badges showing real-time WebSocket connection state.</a:t>
+              <a:t>Displays active session uptime counters and sub-millisecond round-trip latency badges.</a:t>
             </a:r>
           </a:p>
         </p:txBody>
@@ -4967,7 +4967,7 @@
               </a:defRPr>
             </a:pPr>
             <a:r>
-              <a:t>💻  Hardware Classification</a:t>
+              <a:t>🛡️  🛡️ Role-Based Access Control (RBAC)</a:t>
             </a:r>
           </a:p>
           <a:p>
@@ -4979,7 +4979,7 @@
               </a:defRPr>
             </a:pPr>
             <a:r>
-              <a:t>Smart heuristics identify device types and present intuitive custom category icons.</a:t>
+              <a:t>Secure dual-role system (Admin vs User) with bcrypt password hashing and user governance.</a:t>
             </a:r>
           </a:p>
         </p:txBody>
@@ -6627,7 +6627,7 @@
               </a:defRPr>
             </a:pPr>
             <a:r>
-              <a:t>✔  Zero-Configuration Discovery: Runs automatically without complicated terminal setups or manual network configuring.</a:t>
+              <a:t>✔  Zero-Configuration Discovery: Automatically sweeps local subnets and provides targeted unicast (⚡ Probe IP) for custom network nodes.</a:t>
             </a:r>
           </a:p>
           <a:p>
@@ -6642,7 +6642,7 @@
               </a:defRPr>
             </a:pPr>
             <a:r>
-              <a:t>✔  Modern Real-Time UI: Replaces outdated terminal tables with responsive cards, live latency charts, and category filters.</a:t>
+              <a:t>✔  Hardware Brand Recognition: Resolves manufacturer details (Apple, Samsung, Intel, etc.) directly from hardware MAC OUI prefixes.</a:t>
             </a:r>
           </a:p>
           <a:p>
@@ -6657,7 +6657,7 @@
               </a:defRPr>
             </a:pPr>
             <a:r>
-              <a:t>✔  Enterprise-Grade Governance: Combines robust role-based authentication with instant live updates for team visibility.</a:t>
+              <a:t>✔  Auditable DB Persistence: Permanently stores all connection/disconnection logs in SQLite with 1-click CSV report exports.</a:t>
             </a:r>
           </a:p>
           <a:p>
@@ -6672,7 +6672,7 @@
               </a:defRPr>
             </a:pPr>
             <a:r>
-              <a:t>✔  Roadmap Opportunities: Easy to extend with Open Port Scanning (TCP/UDP), Vendor OUI database lookup, and CSV/PDF export.</a:t>
+              <a:t>✔  Enterprise Governance &amp; Live Alerts: Secure dual-role RBAC authentication combined with sub-second WebSocket toast notifications.</a:t>
             </a:r>
           </a:p>
         </p:txBody>

</xml_diff>

<commit_message>
feat: multi-network profile isolation, SSID detection, and network switching
</commit_message>
<xml_diff>
--- a/NetScan_Pro_Presentation.pptx
+++ b/NetScan_Pro_Presentation.pptx
@@ -3918,7 +3918,7 @@
               </a:defRPr>
             </a:pPr>
             <a:r>
-              <a:t>1. Subnet &amp; Interface Auto-Detection — </a:t>
+              <a:t>1. SSID &amp; Network Profile Isolation — </a:t>
             </a:r>
             <a:r>
               <a:rPr sz="1300" b="0">
@@ -3926,7 +3926,7 @@
                   <a:srgbClr val="FFFFFF"/>
                 </a:solidFill>
               </a:rPr>
-              <a:t>Inspects physical network adapters (Wi-Fi/Ethernet) to detect host IP and calculate the CIDR subnet (e.g., 192.168.1.0/24 or 172.20.160.0/19).</a:t>
+              <a:t>Automatically identifies Wi-Fi SSID and adapter CIDR subnet, provisioning an isolated device namespace per network environment.</a:t>
             </a:r>
           </a:p>
         </p:txBody>
@@ -4492,7 +4492,7 @@
               </a:defRPr>
             </a:pPr>
             <a:r>
-              <a:t>🎯  ⚡ On-Demand Target Probing (Probe IP)</a:t>
+              <a:t>🌐  🌐 Multi-Network Profile Isolation</a:t>
             </a:r>
           </a:p>
           <a:p>
@@ -4504,7 +4504,7 @@
               </a:defRPr>
             </a:pPr>
             <a:r>
-              <a:t>Enter any specific IP to send direct ICMP/ARP probes and force-track custom or cross-subnet nodes.</a:t>
+              <a:t>Automatically identifies SSIDs/subnets, isolating devices per Wi-Fi network with an active/historical profile switcher.</a:t>
             </a:r>
           </a:p>
         </p:txBody>
@@ -4587,7 +4587,7 @@
               </a:defRPr>
             </a:pPr>
             <a:r>
-              <a:t>💾  📜 Persistent DB History &amp; CSV Export</a:t>
+              <a:t>🎯  ⚡ On-Demand Target Probing (Probe IP)</a:t>
             </a:r>
           </a:p>
           <a:p>
@@ -4599,7 +4599,7 @@
               </a:defRPr>
             </a:pPr>
             <a:r>
-              <a:t>Full historical audit trail in SQLite recording every connect/disconnect event with 1-click CSV download.</a:t>
+              <a:t>Enter any specific IP to send direct ICMP/ARP probes and force-track custom or cross-subnet nodes.</a:t>
             </a:r>
           </a:p>
         </p:txBody>
@@ -4682,7 +4682,7 @@
               </a:defRPr>
             </a:pPr>
             <a:r>
-              <a:t>🏷️  🏷️ Hardware Vendor Identification</a:t>
+              <a:t>💾  📜 Persistent DB History &amp; CSV Export</a:t>
             </a:r>
           </a:p>
           <a:p>
@@ -4694,7 +4694,7 @@
               </a:defRPr>
             </a:pPr>
             <a:r>
-              <a:t>Automatic MAC OUI dictionary matching identifies Apple, Samsung, OnePlus, Dell, HP, Xiaomi, and Google devices.</a:t>
+              <a:t>Full historical audit trail in SQLite recording every connect/disconnect event with 1-click CSV download.</a:t>
             </a:r>
           </a:p>
         </p:txBody>
@@ -4777,7 +4777,7 @@
               </a:defRPr>
             </a:pPr>
             <a:r>
-              <a:t>🔔  🔔 Real-Time Live Toast Alerts</a:t>
+              <a:t>🏷️  🏷️ Hardware Vendor Identification</a:t>
             </a:r>
           </a:p>
           <a:p>
@@ -4789,7 +4789,7 @@
               </a:defRPr>
             </a:pPr>
             <a:r>
-              <a:t>Instant green/red popups when devices connect or drop off without requiring page reloads.</a:t>
+              <a:t>Automatic MAC OUI dictionary matching identifies Apple, Samsung, OnePlus, Dell, HP, Xiaomi, and Google devices.</a:t>
             </a:r>
           </a:p>
         </p:txBody>
@@ -4872,7 +4872,7 @@
               </a:defRPr>
             </a:pPr>
             <a:r>
-              <a:t>⏱️  ⏱️ Dynamic Live Uptime &amp; Latency</a:t>
+              <a:t>🔔  🔔 Real-Time Live Toast Alerts</a:t>
             </a:r>
           </a:p>
           <a:p>
@@ -4884,7 +4884,7 @@
               </a:defRPr>
             </a:pPr>
             <a:r>
-              <a:t>Displays active session uptime counters and sub-millisecond round-trip latency badges.</a:t>
+              <a:t>Instant green/red popups when devices connect or drop off without requiring page reloads.</a:t>
             </a:r>
           </a:p>
         </p:txBody>
@@ -6613,6 +6613,21 @@
             </a:pPr>
             <a:r>
               <a:t>Why NetScan Pro Stands Out</a:t>
+            </a:r>
+          </a:p>
+          <a:p>
+            <a:pPr>
+              <a:spcAft>
+                <a:spcPts val="1000"/>
+              </a:spcAft>
+              <a:defRPr sz="1400">
+                <a:solidFill>
+                  <a:srgbClr val="FFFFFF"/>
+                </a:solidFill>
+              </a:defRPr>
+            </a:pPr>
+            <a:r>
+              <a:t>✔  Multi-Network Profile Isolation: Automatically detects SSID changes, isolates device tables per Wi-Fi environment, and offers seamless cross-network switching.</a:t>
             </a:r>
           </a:p>
           <a:p>

</xml_diff>